<commit_message>
End-semester review deck: add publishability slide (14 slides)
</commit_message>
<xml_diff>
--- a/docs/end_review_presentation.pptx
+++ b/docs/end_review_presentation.pptx
@@ -18,6 +18,7 @@
     <p:sldId id="266" r:id="rId17"/>
     <p:sldId id="267" r:id="rId18"/>
     <p:sldId id="268" r:id="rId19"/>
+    <p:sldId id="269" r:id="rId20"/>
   </p:sldIdLst>
   <p:sldSz cx="12191695" cy="6858000" type="screen4x3"/>
   <p:notesSz cx="6858000" cy="9144000"/>
@@ -4034,7 +4035,7 @@
                 </a:solidFill>
                 <a:latin typeface="Calibri"/>
               </a:rPr>
-              <a:t>10/13</a:t>
+              <a:t>10/14</a:t>
             </a:r>
           </a:p>
         </p:txBody>
@@ -4724,7 +4725,7 @@
                 </a:solidFill>
                 <a:latin typeface="Calibri"/>
               </a:rPr>
-              <a:t>11/13</a:t>
+              <a:t>11/14</a:t>
             </a:r>
           </a:p>
         </p:txBody>
@@ -5706,7 +5707,7 @@
                 </a:solidFill>
                 <a:latin typeface="Calibri"/>
               </a:rPr>
-              <a:t>12/13</a:t>
+              <a:t>12/14</a:t>
             </a:r>
           </a:p>
         </p:txBody>
@@ -5803,7 +5804,7 @@
                 </a:solidFill>
                 <a:latin typeface="Calibri"/>
               </a:rPr>
-              <a:t>CLOSING</a:t>
+              <a:t>RESEARCH CONTRIBUTION</a:t>
             </a:r>
           </a:p>
         </p:txBody>
@@ -5838,7 +5839,7 @@
                 </a:solidFill>
                 <a:latin typeface="Calibri"/>
               </a:rPr>
-              <a:t>Limitations, Future Work &amp; Team</a:t>
+              <a:t>Why This Could Be Publishable</a:t>
             </a:r>
           </a:p>
         </p:txBody>
@@ -5896,7 +5897,7 @@
         <p:spPr>
           <a:xfrm>
             <a:off x="640080" y="1783080"/>
-            <a:ext cx="5303520" cy="2240280"/>
+            <a:ext cx="5303520" cy="3291840"/>
           </a:xfrm>
           <a:prstGeom prst="rect">
             <a:avLst/>
@@ -5946,7 +5947,7 @@
             <a:avLst/>
           </a:prstGeom>
           <a:solidFill>
-            <a:srgbClr val="DC2626"/>
+            <a:srgbClr val="0F172A"/>
           </a:solidFill>
           <a:ln>
             <a:noFill/>
@@ -6005,7 +6006,7 @@
                 </a:solidFill>
                 <a:latin typeface="Calibri"/>
               </a:rPr>
-              <a:t>LIMITATIONS</a:t>
+              <a:t>WHAT'S NEW</a:t>
             </a:r>
           </a:p>
         </p:txBody>
@@ -6019,7 +6020,7 @@
         <p:spPr>
           <a:xfrm>
             <a:off x="914400" y="2514600"/>
-            <a:ext cx="4754880" cy="1440280"/>
+            <a:ext cx="4754880" cy="2491840"/>
           </a:xfrm>
           <a:prstGeom prst="rect">
             <a:avLst/>
@@ -6047,7 +6048,7 @@
                 </a:solidFill>
                 <a:latin typeface="Calibri"/>
               </a:rPr>
-              <a:t>▸  Kaggle mirror, not official FF++ (access pending)</a:t>
+              <a:t>▸  Explains which transfers invert, not just that they do; prior work reports DF → FS at chance without a cause</a:t>
             </a:r>
           </a:p>
           <a:p>
@@ -6066,7 +6067,7 @@
                 </a:solidFill>
                 <a:latin typeface="Calibri"/>
               </a:rPr>
-              <a:t>▸  Mechanism is a strong candidate, not proof</a:t>
+              <a:t>▸  One measurable cue predicts our matrix (ρ = 0.92) and a published official-data matrix (ρ = 0.73)</a:t>
             </a:r>
           </a:p>
           <a:p>
@@ -6085,155 +6086,9 @@
                 </a:solidFill>
                 <a:latin typeface="Calibri"/>
               </a:rPr>
-              <a:t>▸  One 6 GB laptop GPU limited the experiments</a:t>
-            </a:r>
-          </a:p>
-        </p:txBody>
-      </p:sp>
-      <p:sp>
-        <p:nvSpPr>
-          <p:cNvPr id="10" name="Rectangle 9"/>
-          <p:cNvSpPr/>
-          <p:nvPr/>
-        </p:nvSpPr>
-        <p:spPr>
-          <a:xfrm>
-            <a:off x="6245352" y="1783080"/>
-            <a:ext cx="5303520" cy="2240280"/>
-          </a:xfrm>
-          <a:prstGeom prst="rect">
-            <a:avLst/>
-          </a:prstGeom>
-          <a:solidFill>
-            <a:srgbClr val="F1F5F9"/>
-          </a:solidFill>
-          <a:ln>
-            <a:noFill/>
-          </a:ln>
-          <a:effectLst/>
-        </p:spPr>
-        <p:style>
-          <a:lnRef idx="1">
-            <a:schemeClr val="accent1"/>
-          </a:lnRef>
-          <a:fillRef idx="3">
-            <a:schemeClr val="accent1"/>
-          </a:fillRef>
-          <a:effectRef idx="2">
-            <a:schemeClr val="accent1"/>
-          </a:effectRef>
-          <a:fontRef idx="minor">
-            <a:schemeClr val="lt1"/>
-          </a:fontRef>
-        </p:style>
-        <p:txBody>
-          <a:bodyPr rtlCol="0" anchor="ctr"/>
-          <a:lstStyle/>
-          <a:p>
-            <a:pPr algn="ctr"/>
-          </a:p>
-        </p:txBody>
-      </p:sp>
-      <p:sp>
-        <p:nvSpPr>
-          <p:cNvPr id="11" name="Rectangle 10"/>
-          <p:cNvSpPr/>
-          <p:nvPr/>
-        </p:nvSpPr>
-        <p:spPr>
-          <a:xfrm>
-            <a:off x="6245352" y="1783080"/>
-            <a:ext cx="5303520" cy="502920"/>
-          </a:xfrm>
-          <a:prstGeom prst="rect">
-            <a:avLst/>
-          </a:prstGeom>
-          <a:solidFill>
-            <a:srgbClr val="0E7490"/>
-          </a:solidFill>
-          <a:ln>
-            <a:noFill/>
-          </a:ln>
-          <a:effectLst/>
-        </p:spPr>
-        <p:style>
-          <a:lnRef idx="1">
-            <a:schemeClr val="accent1"/>
-          </a:lnRef>
-          <a:fillRef idx="3">
-            <a:schemeClr val="accent1"/>
-          </a:fillRef>
-          <a:effectRef idx="2">
-            <a:schemeClr val="accent1"/>
-          </a:effectRef>
-          <a:fontRef idx="minor">
-            <a:schemeClr val="lt1"/>
-          </a:fontRef>
-        </p:style>
-        <p:txBody>
-          <a:bodyPr rtlCol="0" anchor="ctr"/>
-          <a:lstStyle/>
-          <a:p>
-            <a:pPr algn="ctr"/>
-          </a:p>
-        </p:txBody>
-      </p:sp>
-      <p:sp>
-        <p:nvSpPr>
-          <p:cNvPr id="12" name="TextBox 11"/>
-          <p:cNvSpPr txBox="1"/>
-          <p:nvPr/>
-        </p:nvSpPr>
-        <p:spPr>
-          <a:xfrm>
-            <a:off x="6519672" y="1901952"/>
-            <a:ext cx="4754880" cy="320040"/>
-          </a:xfrm>
-          <a:prstGeom prst="rect">
-            <a:avLst/>
-          </a:prstGeom>
-          <a:noFill/>
-        </p:spPr>
-        <p:txBody>
-          <a:bodyPr wrap="square">
-            <a:spAutoFit/>
-          </a:bodyPr>
-          <a:lstStyle/>
-          <a:p>
-            <a:pPr algn="l"/>
-            <a:r>
-              <a:rPr sz="1400" b="1">
-                <a:solidFill>
-                  <a:srgbClr val="FFFFFF"/>
-                </a:solidFill>
-                <a:latin typeface="Calibri"/>
-              </a:rPr>
-              <a:t>FUTURE WORK</a:t>
-            </a:r>
-          </a:p>
-        </p:txBody>
-      </p:sp>
-      <p:sp>
-        <p:nvSpPr>
-          <p:cNvPr id="13" name="TextBox 12"/>
-          <p:cNvSpPr txBox="1"/>
-          <p:nvPr/>
-        </p:nvSpPr>
-        <p:spPr>
-          <a:xfrm>
-            <a:off x="6519672" y="2514600"/>
-            <a:ext cx="4754880" cy="1440280"/>
-          </a:xfrm>
-          <a:prstGeom prst="rect">
-            <a:avLst/>
-          </a:prstGeom>
-          <a:noFill/>
-        </p:spPr>
-        <p:txBody>
-          <a:bodyPr wrap="square">
-            <a:spAutoFit/>
-          </a:bodyPr>
-          <a:lstStyle/>
+              <a:t>▸  Causal test: removing the cue raises the inverted cells (DF → FS +0.098, FS → NT +0.093 AUC)</a:t>
+            </a:r>
+          </a:p>
           <a:p>
             <a:pPr>
               <a:lnSpc>
@@ -6250,9 +6105,155 @@
                 </a:solidFill>
                 <a:latin typeface="Calibri"/>
               </a:rPr>
-              <a:t>▸  Re-run on official FaceForensics++</a:t>
-            </a:r>
-          </a:p>
+              <a:t>▸  Architecture-independent: 3 backbones agree in 8/8 cells</a:t>
+            </a:r>
+          </a:p>
+        </p:txBody>
+      </p:sp>
+      <p:sp>
+        <p:nvSpPr>
+          <p:cNvPr id="10" name="Rectangle 9"/>
+          <p:cNvSpPr/>
+          <p:nvPr/>
+        </p:nvSpPr>
+        <p:spPr>
+          <a:xfrm>
+            <a:off x="6245352" y="1783080"/>
+            <a:ext cx="5303520" cy="3291840"/>
+          </a:xfrm>
+          <a:prstGeom prst="rect">
+            <a:avLst/>
+          </a:prstGeom>
+          <a:solidFill>
+            <a:srgbClr val="F1F5F9"/>
+          </a:solidFill>
+          <a:ln>
+            <a:noFill/>
+          </a:ln>
+          <a:effectLst/>
+        </p:spPr>
+        <p:style>
+          <a:lnRef idx="1">
+            <a:schemeClr val="accent1"/>
+          </a:lnRef>
+          <a:fillRef idx="3">
+            <a:schemeClr val="accent1"/>
+          </a:fillRef>
+          <a:effectRef idx="2">
+            <a:schemeClr val="accent1"/>
+          </a:effectRef>
+          <a:fontRef idx="minor">
+            <a:schemeClr val="lt1"/>
+          </a:fontRef>
+        </p:style>
+        <p:txBody>
+          <a:bodyPr rtlCol="0" anchor="ctr"/>
+          <a:lstStyle/>
+          <a:p>
+            <a:pPr algn="ctr"/>
+          </a:p>
+        </p:txBody>
+      </p:sp>
+      <p:sp>
+        <p:nvSpPr>
+          <p:cNvPr id="11" name="Rectangle 10"/>
+          <p:cNvSpPr/>
+          <p:nvPr/>
+        </p:nvSpPr>
+        <p:spPr>
+          <a:xfrm>
+            <a:off x="6245352" y="1783080"/>
+            <a:ext cx="5303520" cy="502920"/>
+          </a:xfrm>
+          <a:prstGeom prst="rect">
+            <a:avLst/>
+          </a:prstGeom>
+          <a:solidFill>
+            <a:srgbClr val="0E7490"/>
+          </a:solidFill>
+          <a:ln>
+            <a:noFill/>
+          </a:ln>
+          <a:effectLst/>
+        </p:spPr>
+        <p:style>
+          <a:lnRef idx="1">
+            <a:schemeClr val="accent1"/>
+          </a:lnRef>
+          <a:fillRef idx="3">
+            <a:schemeClr val="accent1"/>
+          </a:fillRef>
+          <a:effectRef idx="2">
+            <a:schemeClr val="accent1"/>
+          </a:effectRef>
+          <a:fontRef idx="minor">
+            <a:schemeClr val="lt1"/>
+          </a:fontRef>
+        </p:style>
+        <p:txBody>
+          <a:bodyPr rtlCol="0" anchor="ctr"/>
+          <a:lstStyle/>
+          <a:p>
+            <a:pPr algn="ctr"/>
+          </a:p>
+        </p:txBody>
+      </p:sp>
+      <p:sp>
+        <p:nvSpPr>
+          <p:cNvPr id="12" name="TextBox 11"/>
+          <p:cNvSpPr txBox="1"/>
+          <p:nvPr/>
+        </p:nvSpPr>
+        <p:spPr>
+          <a:xfrm>
+            <a:off x="6519672" y="1901952"/>
+            <a:ext cx="4754880" cy="320040"/>
+          </a:xfrm>
+          <a:prstGeom prst="rect">
+            <a:avLst/>
+          </a:prstGeom>
+          <a:noFill/>
+        </p:spPr>
+        <p:txBody>
+          <a:bodyPr wrap="square">
+            <a:spAutoFit/>
+          </a:bodyPr>
+          <a:lstStyle/>
+          <a:p>
+            <a:pPr algn="l"/>
+            <a:r>
+              <a:rPr sz="1400" b="1">
+                <a:solidFill>
+                  <a:srgbClr val="FFFFFF"/>
+                </a:solidFill>
+                <a:latin typeface="Calibri"/>
+              </a:rPr>
+              <a:t>WHY IT'S CREDIBLE</a:t>
+            </a:r>
+          </a:p>
+        </p:txBody>
+      </p:sp>
+      <p:sp>
+        <p:nvSpPr>
+          <p:cNvPr id="13" name="TextBox 12"/>
+          <p:cNvSpPr txBox="1"/>
+          <p:nvPr/>
+        </p:nvSpPr>
+        <p:spPr>
+          <a:xfrm>
+            <a:off x="6519672" y="2514600"/>
+            <a:ext cx="4754880" cy="2491840"/>
+          </a:xfrm>
+          <a:prstGeom prst="rect">
+            <a:avLst/>
+          </a:prstGeom>
+          <a:noFill/>
+        </p:spPr>
+        <p:txBody>
+          <a:bodyPr wrap="square">
+            <a:spAutoFit/>
+          </a:bodyPr>
+          <a:lstStyle/>
           <a:p>
             <a:pPr>
               <a:lnSpc>
@@ -6269,7 +6270,7 @@
                 </a:solidFill>
                 <a:latin typeface="Calibri"/>
               </a:rPr>
-              <a:t>▸  Find the cue behind the remaining DF → FS gap</a:t>
+              <a:t>▸  Predictions recorded before results, and misses reported</a:t>
             </a:r>
           </a:p>
           <a:p>
@@ -6288,6 +6289,805 @@
                 </a:solidFill>
                 <a:latin typeface="Calibri"/>
               </a:rPr>
+              <a:t>▸  3 seeds, bootstrap confidence intervals, paired tests</a:t>
+            </a:r>
+          </a:p>
+          <a:p>
+            <a:pPr>
+              <a:lnSpc>
+                <a:spcPct val="112000"/>
+              </a:lnSpc>
+              <a:spcAft>
+                <a:spcPts val="800"/>
+              </a:spcAft>
+            </a:pPr>
+            <a:r>
+              <a:rPr sz="1250" b="1">
+                <a:solidFill>
+                  <a:srgbClr val="1A202C"/>
+                </a:solidFill>
+                <a:latin typeface="Calibri"/>
+              </a:rPr>
+              <a:t>▸  Audit and full pipeline rebuild rule out artifacts</a:t>
+            </a:r>
+          </a:p>
+          <a:p>
+            <a:pPr>
+              <a:lnSpc>
+                <a:spcPct val="112000"/>
+              </a:lnSpc>
+              <a:spcAft>
+                <a:spcPts val="800"/>
+              </a:spcAft>
+            </a:pPr>
+            <a:r>
+              <a:rPr sz="1250" b="1">
+                <a:solidFill>
+                  <a:srgbClr val="1A202C"/>
+                </a:solidFill>
+                <a:latin typeface="Calibri"/>
+              </a:rPr>
+              <a:t>▸  Every number regenerated by scripts; code is public</a:t>
+            </a:r>
+          </a:p>
+        </p:txBody>
+      </p:sp>
+      <p:sp>
+        <p:nvSpPr>
+          <p:cNvPr id="14" name="Rectangle 13"/>
+          <p:cNvSpPr/>
+          <p:nvPr/>
+        </p:nvSpPr>
+        <p:spPr>
+          <a:xfrm>
+            <a:off x="640080" y="5303520"/>
+            <a:ext cx="10908792" cy="868680"/>
+          </a:xfrm>
+          <a:prstGeom prst="rect">
+            <a:avLst/>
+          </a:prstGeom>
+          <a:solidFill>
+            <a:srgbClr val="F1F5F9"/>
+          </a:solidFill>
+          <a:ln>
+            <a:noFill/>
+          </a:ln>
+          <a:effectLst/>
+        </p:spPr>
+        <p:style>
+          <a:lnRef idx="1">
+            <a:schemeClr val="accent1"/>
+          </a:lnRef>
+          <a:fillRef idx="3">
+            <a:schemeClr val="accent1"/>
+          </a:fillRef>
+          <a:effectRef idx="2">
+            <a:schemeClr val="accent1"/>
+          </a:effectRef>
+          <a:fontRef idx="minor">
+            <a:schemeClr val="lt1"/>
+          </a:fontRef>
+        </p:style>
+        <p:txBody>
+          <a:bodyPr rtlCol="0" anchor="ctr"/>
+          <a:lstStyle/>
+          <a:p>
+            <a:pPr algn="ctr"/>
+          </a:p>
+        </p:txBody>
+      </p:sp>
+      <p:sp>
+        <p:nvSpPr>
+          <p:cNvPr id="15" name="TextBox 14"/>
+          <p:cNvSpPr txBox="1"/>
+          <p:nvPr/>
+        </p:nvSpPr>
+        <p:spPr>
+          <a:xfrm>
+            <a:off x="868680" y="5376672"/>
+            <a:ext cx="10424160" cy="731520"/>
+          </a:xfrm>
+          <a:prstGeom prst="rect">
+            <a:avLst/>
+          </a:prstGeom>
+          <a:noFill/>
+        </p:spPr>
+        <p:txBody>
+          <a:bodyPr wrap="square">
+            <a:spAutoFit/>
+          </a:bodyPr>
+          <a:lstStyle/>
+          <a:p>
+            <a:pPr algn="l"/>
+            <a:r>
+              <a:rPr sz="1300" b="1">
+                <a:solidFill>
+                  <a:srgbClr val="0E7490"/>
+                </a:solidFill>
+                <a:latin typeface="Calibri"/>
+              </a:rPr>
+              <a:t>Best fit: </a:t>
+            </a:r>
+            <a:r>
+              <a:rPr sz="1300" b="0">
+                <a:solidFill>
+                  <a:srgbClr val="1A202C"/>
+                </a:solidFill>
+                <a:latin typeface="Calibri"/>
+              </a:rPr>
+              <a:t>a workshop or short-paper track (e.g. IEEE WIFS); draft ready in paper/main.pdf.</a:t>
+            </a:r>
+          </a:p>
+          <a:p>
+            <a:pPr algn="l"/>
+            <a:r>
+              <a:rPr sz="1300" b="1">
+                <a:solidFill>
+                  <a:srgbClr val="DC2626"/>
+                </a:solidFill>
+                <a:latin typeface="Calibri"/>
+              </a:rPr>
+              <a:t>Risks a reviewer will raise: </a:t>
+            </a:r>
+            <a:r>
+              <a:rPr sz="1300" b="0">
+                <a:solidFill>
+                  <a:srgbClr val="1A202C"/>
+                </a:solidFill>
+                <a:latin typeface="Calibri"/>
+              </a:rPr>
+              <a:t>unofficial data mirror, a partial fix, no transfer to DeepFakeFace (all stated openly).</a:t>
+            </a:r>
+          </a:p>
+        </p:txBody>
+      </p:sp>
+      <p:sp>
+        <p:nvSpPr>
+          <p:cNvPr id="16" name="TextBox 15"/>
+          <p:cNvSpPr txBox="1"/>
+          <p:nvPr/>
+        </p:nvSpPr>
+        <p:spPr>
+          <a:xfrm>
+            <a:off x="640080" y="6510528"/>
+            <a:ext cx="7315200" cy="274320"/>
+          </a:xfrm>
+          <a:prstGeom prst="rect">
+            <a:avLst/>
+          </a:prstGeom>
+          <a:noFill/>
+        </p:spPr>
+        <p:txBody>
+          <a:bodyPr wrap="square">
+            <a:spAutoFit/>
+          </a:bodyPr>
+          <a:lstStyle/>
+          <a:p>
+            <a:pPr algn="l"/>
+            <a:r>
+              <a:rPr sz="1000" b="0">
+                <a:solidFill>
+                  <a:srgbClr val="94A3B8"/>
+                </a:solidFill>
+                <a:latin typeface="Calibri"/>
+              </a:rPr>
+              <a:t>Deepfake Detection — End-Semester Review (23AID205)</a:t>
+            </a:r>
+          </a:p>
+        </p:txBody>
+      </p:sp>
+      <p:sp>
+        <p:nvSpPr>
+          <p:cNvPr id="17" name="TextBox 16"/>
+          <p:cNvSpPr txBox="1"/>
+          <p:nvPr/>
+        </p:nvSpPr>
+        <p:spPr>
+          <a:xfrm>
+            <a:off x="10972800" y="6510528"/>
+            <a:ext cx="822960" cy="274320"/>
+          </a:xfrm>
+          <a:prstGeom prst="rect">
+            <a:avLst/>
+          </a:prstGeom>
+          <a:noFill/>
+        </p:spPr>
+        <p:txBody>
+          <a:bodyPr wrap="square">
+            <a:spAutoFit/>
+          </a:bodyPr>
+          <a:lstStyle/>
+          <a:p>
+            <a:pPr algn="r"/>
+            <a:r>
+              <a:rPr sz="1000" b="0">
+                <a:solidFill>
+                  <a:srgbClr val="94A3B8"/>
+                </a:solidFill>
+                <a:latin typeface="Calibri"/>
+              </a:rPr>
+              <a:t>13/14</a:t>
+            </a:r>
+          </a:p>
+        </p:txBody>
+      </p:sp>
+    </p:spTree>
+  </p:cSld>
+  <p:clrMapOvr>
+    <a:masterClrMapping/>
+  </p:clrMapOvr>
+</p:sld>
+</file>
+
+<file path=ppt/slides/slide14.xml><?xml version="1.0" encoding="utf-8"?>
+<p:sld xmlns:a="http://schemas.openxmlformats.org/drawingml/2006/main" xmlns:p="http://schemas.openxmlformats.org/presentationml/2006/main" xmlns:r="http://schemas.openxmlformats.org/officeDocument/2006/relationships">
+  <p:cSld>
+    <p:spTree>
+      <p:nvGrpSpPr>
+        <p:cNvPr id="1" name=""/>
+        <p:cNvGrpSpPr/>
+        <p:nvPr/>
+      </p:nvGrpSpPr>
+      <p:grpSpPr/>
+      <p:sp>
+        <p:nvSpPr>
+          <p:cNvPr id="2" name="Rectangle 1"/>
+          <p:cNvSpPr/>
+          <p:nvPr/>
+        </p:nvSpPr>
+        <p:spPr>
+          <a:xfrm>
+            <a:off x="0" y="0"/>
+            <a:ext cx="12191695" cy="6858000"/>
+          </a:xfrm>
+          <a:prstGeom prst="rect">
+            <a:avLst/>
+          </a:prstGeom>
+          <a:solidFill>
+            <a:srgbClr val="FFFFFF"/>
+          </a:solidFill>
+          <a:ln>
+            <a:noFill/>
+          </a:ln>
+          <a:effectLst/>
+        </p:spPr>
+        <p:style>
+          <a:lnRef idx="1">
+            <a:schemeClr val="accent1"/>
+          </a:lnRef>
+          <a:fillRef idx="3">
+            <a:schemeClr val="accent1"/>
+          </a:fillRef>
+          <a:effectRef idx="2">
+            <a:schemeClr val="accent1"/>
+          </a:effectRef>
+          <a:fontRef idx="minor">
+            <a:schemeClr val="lt1"/>
+          </a:fontRef>
+        </p:style>
+        <p:txBody>
+          <a:bodyPr rtlCol="0" anchor="ctr"/>
+          <a:lstStyle/>
+          <a:p>
+            <a:pPr algn="ctr"/>
+          </a:p>
+        </p:txBody>
+      </p:sp>
+      <p:sp>
+        <p:nvSpPr>
+          <p:cNvPr id="3" name="TextBox 2"/>
+          <p:cNvSpPr txBox="1"/>
+          <p:nvPr/>
+        </p:nvSpPr>
+        <p:spPr>
+          <a:xfrm>
+            <a:off x="640080" y="384048"/>
+            <a:ext cx="9144000" cy="320040"/>
+          </a:xfrm>
+          <a:prstGeom prst="rect">
+            <a:avLst/>
+          </a:prstGeom>
+          <a:noFill/>
+        </p:spPr>
+        <p:txBody>
+          <a:bodyPr wrap="square">
+            <a:spAutoFit/>
+          </a:bodyPr>
+          <a:lstStyle/>
+          <a:p>
+            <a:pPr algn="l"/>
+            <a:r>
+              <a:rPr sz="1300" b="1">
+                <a:solidFill>
+                  <a:srgbClr val="0E7490"/>
+                </a:solidFill>
+                <a:latin typeface="Calibri"/>
+              </a:rPr>
+              <a:t>CLOSING</a:t>
+            </a:r>
+          </a:p>
+        </p:txBody>
+      </p:sp>
+      <p:sp>
+        <p:nvSpPr>
+          <p:cNvPr id="4" name="TextBox 3"/>
+          <p:cNvSpPr txBox="1"/>
+          <p:nvPr/>
+        </p:nvSpPr>
+        <p:spPr>
+          <a:xfrm>
+            <a:off x="640080" y="658368"/>
+            <a:ext cx="10852800" cy="731520"/>
+          </a:xfrm>
+          <a:prstGeom prst="rect">
+            <a:avLst/>
+          </a:prstGeom>
+          <a:noFill/>
+        </p:spPr>
+        <p:txBody>
+          <a:bodyPr wrap="square">
+            <a:spAutoFit/>
+          </a:bodyPr>
+          <a:lstStyle/>
+          <a:p>
+            <a:pPr algn="l"/>
+            <a:r>
+              <a:rPr sz="2800" b="1">
+                <a:solidFill>
+                  <a:srgbClr val="1A202C"/>
+                </a:solidFill>
+                <a:latin typeface="Calibri"/>
+              </a:rPr>
+              <a:t>Limitations, Future Work &amp; Team</a:t>
+            </a:r>
+          </a:p>
+        </p:txBody>
+      </p:sp>
+      <p:sp>
+        <p:nvSpPr>
+          <p:cNvPr id="5" name="Rectangle 4"/>
+          <p:cNvSpPr/>
+          <p:nvPr/>
+        </p:nvSpPr>
+        <p:spPr>
+          <a:xfrm>
+            <a:off x="640080" y="1353312"/>
+            <a:ext cx="502920" cy="41148"/>
+          </a:xfrm>
+          <a:prstGeom prst="rect">
+            <a:avLst/>
+          </a:prstGeom>
+          <a:solidFill>
+            <a:srgbClr val="22B8CF"/>
+          </a:solidFill>
+          <a:ln>
+            <a:noFill/>
+          </a:ln>
+          <a:effectLst/>
+        </p:spPr>
+        <p:style>
+          <a:lnRef idx="1">
+            <a:schemeClr val="accent1"/>
+          </a:lnRef>
+          <a:fillRef idx="3">
+            <a:schemeClr val="accent1"/>
+          </a:fillRef>
+          <a:effectRef idx="2">
+            <a:schemeClr val="accent1"/>
+          </a:effectRef>
+          <a:fontRef idx="minor">
+            <a:schemeClr val="lt1"/>
+          </a:fontRef>
+        </p:style>
+        <p:txBody>
+          <a:bodyPr rtlCol="0" anchor="ctr"/>
+          <a:lstStyle/>
+          <a:p>
+            <a:pPr algn="ctr"/>
+          </a:p>
+        </p:txBody>
+      </p:sp>
+      <p:sp>
+        <p:nvSpPr>
+          <p:cNvPr id="6" name="Rectangle 5"/>
+          <p:cNvSpPr/>
+          <p:nvPr/>
+        </p:nvSpPr>
+        <p:spPr>
+          <a:xfrm>
+            <a:off x="640080" y="1783080"/>
+            <a:ext cx="5303520" cy="2240280"/>
+          </a:xfrm>
+          <a:prstGeom prst="rect">
+            <a:avLst/>
+          </a:prstGeom>
+          <a:solidFill>
+            <a:srgbClr val="F1F5F9"/>
+          </a:solidFill>
+          <a:ln>
+            <a:noFill/>
+          </a:ln>
+          <a:effectLst/>
+        </p:spPr>
+        <p:style>
+          <a:lnRef idx="1">
+            <a:schemeClr val="accent1"/>
+          </a:lnRef>
+          <a:fillRef idx="3">
+            <a:schemeClr val="accent1"/>
+          </a:fillRef>
+          <a:effectRef idx="2">
+            <a:schemeClr val="accent1"/>
+          </a:effectRef>
+          <a:fontRef idx="minor">
+            <a:schemeClr val="lt1"/>
+          </a:fontRef>
+        </p:style>
+        <p:txBody>
+          <a:bodyPr rtlCol="0" anchor="ctr"/>
+          <a:lstStyle/>
+          <a:p>
+            <a:pPr algn="ctr"/>
+          </a:p>
+        </p:txBody>
+      </p:sp>
+      <p:sp>
+        <p:nvSpPr>
+          <p:cNvPr id="7" name="Rectangle 6"/>
+          <p:cNvSpPr/>
+          <p:nvPr/>
+        </p:nvSpPr>
+        <p:spPr>
+          <a:xfrm>
+            <a:off x="640080" y="1783080"/>
+            <a:ext cx="5303520" cy="502920"/>
+          </a:xfrm>
+          <a:prstGeom prst="rect">
+            <a:avLst/>
+          </a:prstGeom>
+          <a:solidFill>
+            <a:srgbClr val="DC2626"/>
+          </a:solidFill>
+          <a:ln>
+            <a:noFill/>
+          </a:ln>
+          <a:effectLst/>
+        </p:spPr>
+        <p:style>
+          <a:lnRef idx="1">
+            <a:schemeClr val="accent1"/>
+          </a:lnRef>
+          <a:fillRef idx="3">
+            <a:schemeClr val="accent1"/>
+          </a:fillRef>
+          <a:effectRef idx="2">
+            <a:schemeClr val="accent1"/>
+          </a:effectRef>
+          <a:fontRef idx="minor">
+            <a:schemeClr val="lt1"/>
+          </a:fontRef>
+        </p:style>
+        <p:txBody>
+          <a:bodyPr rtlCol="0" anchor="ctr"/>
+          <a:lstStyle/>
+          <a:p>
+            <a:pPr algn="ctr"/>
+          </a:p>
+        </p:txBody>
+      </p:sp>
+      <p:sp>
+        <p:nvSpPr>
+          <p:cNvPr id="8" name="TextBox 7"/>
+          <p:cNvSpPr txBox="1"/>
+          <p:nvPr/>
+        </p:nvSpPr>
+        <p:spPr>
+          <a:xfrm>
+            <a:off x="914400" y="1901952"/>
+            <a:ext cx="4754880" cy="320040"/>
+          </a:xfrm>
+          <a:prstGeom prst="rect">
+            <a:avLst/>
+          </a:prstGeom>
+          <a:noFill/>
+        </p:spPr>
+        <p:txBody>
+          <a:bodyPr wrap="square">
+            <a:spAutoFit/>
+          </a:bodyPr>
+          <a:lstStyle/>
+          <a:p>
+            <a:pPr algn="l"/>
+            <a:r>
+              <a:rPr sz="1400" b="1">
+                <a:solidFill>
+                  <a:srgbClr val="FFFFFF"/>
+                </a:solidFill>
+                <a:latin typeface="Calibri"/>
+              </a:rPr>
+              <a:t>LIMITATIONS</a:t>
+            </a:r>
+          </a:p>
+        </p:txBody>
+      </p:sp>
+      <p:sp>
+        <p:nvSpPr>
+          <p:cNvPr id="9" name="TextBox 8"/>
+          <p:cNvSpPr txBox="1"/>
+          <p:nvPr/>
+        </p:nvSpPr>
+        <p:spPr>
+          <a:xfrm>
+            <a:off x="914400" y="2514600"/>
+            <a:ext cx="4754880" cy="1440280"/>
+          </a:xfrm>
+          <a:prstGeom prst="rect">
+            <a:avLst/>
+          </a:prstGeom>
+          <a:noFill/>
+        </p:spPr>
+        <p:txBody>
+          <a:bodyPr wrap="square">
+            <a:spAutoFit/>
+          </a:bodyPr>
+          <a:lstStyle/>
+          <a:p>
+            <a:pPr>
+              <a:lnSpc>
+                <a:spcPct val="112000"/>
+              </a:lnSpc>
+              <a:spcAft>
+                <a:spcPts val="800"/>
+              </a:spcAft>
+            </a:pPr>
+            <a:r>
+              <a:rPr sz="1250" b="1">
+                <a:solidFill>
+                  <a:srgbClr val="1A202C"/>
+                </a:solidFill>
+                <a:latin typeface="Calibri"/>
+              </a:rPr>
+              <a:t>▸  Kaggle mirror, not official FF++ (access pending)</a:t>
+            </a:r>
+          </a:p>
+          <a:p>
+            <a:pPr>
+              <a:lnSpc>
+                <a:spcPct val="112000"/>
+              </a:lnSpc>
+              <a:spcAft>
+                <a:spcPts val="800"/>
+              </a:spcAft>
+            </a:pPr>
+            <a:r>
+              <a:rPr sz="1250" b="1">
+                <a:solidFill>
+                  <a:srgbClr val="1A202C"/>
+                </a:solidFill>
+                <a:latin typeface="Calibri"/>
+              </a:rPr>
+              <a:t>▸  Mechanism is a strong candidate, not proof</a:t>
+            </a:r>
+          </a:p>
+          <a:p>
+            <a:pPr>
+              <a:lnSpc>
+                <a:spcPct val="112000"/>
+              </a:lnSpc>
+              <a:spcAft>
+                <a:spcPts val="800"/>
+              </a:spcAft>
+            </a:pPr>
+            <a:r>
+              <a:rPr sz="1250" b="1">
+                <a:solidFill>
+                  <a:srgbClr val="1A202C"/>
+                </a:solidFill>
+                <a:latin typeface="Calibri"/>
+              </a:rPr>
+              <a:t>▸  One 6 GB laptop GPU limited the experiments</a:t>
+            </a:r>
+          </a:p>
+        </p:txBody>
+      </p:sp>
+      <p:sp>
+        <p:nvSpPr>
+          <p:cNvPr id="10" name="Rectangle 9"/>
+          <p:cNvSpPr/>
+          <p:nvPr/>
+        </p:nvSpPr>
+        <p:spPr>
+          <a:xfrm>
+            <a:off x="6245352" y="1783080"/>
+            <a:ext cx="5303520" cy="2240280"/>
+          </a:xfrm>
+          <a:prstGeom prst="rect">
+            <a:avLst/>
+          </a:prstGeom>
+          <a:solidFill>
+            <a:srgbClr val="F1F5F9"/>
+          </a:solidFill>
+          <a:ln>
+            <a:noFill/>
+          </a:ln>
+          <a:effectLst/>
+        </p:spPr>
+        <p:style>
+          <a:lnRef idx="1">
+            <a:schemeClr val="accent1"/>
+          </a:lnRef>
+          <a:fillRef idx="3">
+            <a:schemeClr val="accent1"/>
+          </a:fillRef>
+          <a:effectRef idx="2">
+            <a:schemeClr val="accent1"/>
+          </a:effectRef>
+          <a:fontRef idx="minor">
+            <a:schemeClr val="lt1"/>
+          </a:fontRef>
+        </p:style>
+        <p:txBody>
+          <a:bodyPr rtlCol="0" anchor="ctr"/>
+          <a:lstStyle/>
+          <a:p>
+            <a:pPr algn="ctr"/>
+          </a:p>
+        </p:txBody>
+      </p:sp>
+      <p:sp>
+        <p:nvSpPr>
+          <p:cNvPr id="11" name="Rectangle 10"/>
+          <p:cNvSpPr/>
+          <p:nvPr/>
+        </p:nvSpPr>
+        <p:spPr>
+          <a:xfrm>
+            <a:off x="6245352" y="1783080"/>
+            <a:ext cx="5303520" cy="502920"/>
+          </a:xfrm>
+          <a:prstGeom prst="rect">
+            <a:avLst/>
+          </a:prstGeom>
+          <a:solidFill>
+            <a:srgbClr val="0E7490"/>
+          </a:solidFill>
+          <a:ln>
+            <a:noFill/>
+          </a:ln>
+          <a:effectLst/>
+        </p:spPr>
+        <p:style>
+          <a:lnRef idx="1">
+            <a:schemeClr val="accent1"/>
+          </a:lnRef>
+          <a:fillRef idx="3">
+            <a:schemeClr val="accent1"/>
+          </a:fillRef>
+          <a:effectRef idx="2">
+            <a:schemeClr val="accent1"/>
+          </a:effectRef>
+          <a:fontRef idx="minor">
+            <a:schemeClr val="lt1"/>
+          </a:fontRef>
+        </p:style>
+        <p:txBody>
+          <a:bodyPr rtlCol="0" anchor="ctr"/>
+          <a:lstStyle/>
+          <a:p>
+            <a:pPr algn="ctr"/>
+          </a:p>
+        </p:txBody>
+      </p:sp>
+      <p:sp>
+        <p:nvSpPr>
+          <p:cNvPr id="12" name="TextBox 11"/>
+          <p:cNvSpPr txBox="1"/>
+          <p:nvPr/>
+        </p:nvSpPr>
+        <p:spPr>
+          <a:xfrm>
+            <a:off x="6519672" y="1901952"/>
+            <a:ext cx="4754880" cy="320040"/>
+          </a:xfrm>
+          <a:prstGeom prst="rect">
+            <a:avLst/>
+          </a:prstGeom>
+          <a:noFill/>
+        </p:spPr>
+        <p:txBody>
+          <a:bodyPr wrap="square">
+            <a:spAutoFit/>
+          </a:bodyPr>
+          <a:lstStyle/>
+          <a:p>
+            <a:pPr algn="l"/>
+            <a:r>
+              <a:rPr sz="1400" b="1">
+                <a:solidFill>
+                  <a:srgbClr val="FFFFFF"/>
+                </a:solidFill>
+                <a:latin typeface="Calibri"/>
+              </a:rPr>
+              <a:t>FUTURE WORK</a:t>
+            </a:r>
+          </a:p>
+        </p:txBody>
+      </p:sp>
+      <p:sp>
+        <p:nvSpPr>
+          <p:cNvPr id="13" name="TextBox 12"/>
+          <p:cNvSpPr txBox="1"/>
+          <p:nvPr/>
+        </p:nvSpPr>
+        <p:spPr>
+          <a:xfrm>
+            <a:off x="6519672" y="2514600"/>
+            <a:ext cx="4754880" cy="1440280"/>
+          </a:xfrm>
+          <a:prstGeom prst="rect">
+            <a:avLst/>
+          </a:prstGeom>
+          <a:noFill/>
+        </p:spPr>
+        <p:txBody>
+          <a:bodyPr wrap="square">
+            <a:spAutoFit/>
+          </a:bodyPr>
+          <a:lstStyle/>
+          <a:p>
+            <a:pPr>
+              <a:lnSpc>
+                <a:spcPct val="112000"/>
+              </a:lnSpc>
+              <a:spcAft>
+                <a:spcPts val="800"/>
+              </a:spcAft>
+            </a:pPr>
+            <a:r>
+              <a:rPr sz="1250" b="1">
+                <a:solidFill>
+                  <a:srgbClr val="1A202C"/>
+                </a:solidFill>
+                <a:latin typeface="Calibri"/>
+              </a:rPr>
+              <a:t>▸  Re-run on official FaceForensics++</a:t>
+            </a:r>
+          </a:p>
+          <a:p>
+            <a:pPr>
+              <a:lnSpc>
+                <a:spcPct val="112000"/>
+              </a:lnSpc>
+              <a:spcAft>
+                <a:spcPts val="800"/>
+              </a:spcAft>
+            </a:pPr>
+            <a:r>
+              <a:rPr sz="1250" b="1">
+                <a:solidFill>
+                  <a:srgbClr val="1A202C"/>
+                </a:solidFill>
+                <a:latin typeface="Calibri"/>
+              </a:rPr>
+              <a:t>▸  Find the cue behind the remaining DF → FS gap</a:t>
+            </a:r>
+          </a:p>
+          <a:p>
+            <a:pPr>
+              <a:lnSpc>
+                <a:spcPct val="112000"/>
+              </a:lnSpc>
+              <a:spcAft>
+                <a:spcPts val="800"/>
+              </a:spcAft>
+            </a:pPr>
+            <a:r>
+              <a:rPr sz="1250" b="1">
+                <a:solidFill>
+                  <a:srgbClr val="1A202C"/>
+                </a:solidFill>
+                <a:latin typeface="Calibri"/>
+              </a:rPr>
               <a:t>▸  Submit a short paper (draft: paper/main.pdf)</a:t>
             </a:r>
           </a:p>
@@ -6533,7 +7333,7 @@
                 </a:solidFill>
                 <a:latin typeface="Calibri"/>
               </a:rPr>
-              <a:t>13/13</a:t>
+              <a:t>14/14</a:t>
             </a:r>
           </a:p>
         </p:txBody>
@@ -6878,7 +7678,7 @@
                 </a:solidFill>
                 <a:latin typeface="Calibri"/>
               </a:rPr>
-              <a:t>2/13</a:t>
+              <a:t>2/14</a:t>
             </a:r>
           </a:p>
         </p:txBody>
@@ -8317,7 +9117,7 @@
                 </a:solidFill>
                 <a:latin typeface="Calibri"/>
               </a:rPr>
-              <a:t>3/13</a:t>
+              <a:t>3/14</a:t>
             </a:r>
           </a:p>
         </p:txBody>
@@ -9111,7 +9911,7 @@
                 </a:solidFill>
                 <a:latin typeface="Calibri"/>
               </a:rPr>
-              <a:t>4/13</a:t>
+              <a:t>4/14</a:t>
             </a:r>
           </a:p>
         </p:txBody>
@@ -9725,7 +10525,7 @@
                 </a:solidFill>
                 <a:latin typeface="Calibri"/>
               </a:rPr>
-              <a:t>5/13</a:t>
+              <a:t>5/14</a:t>
             </a:r>
           </a:p>
         </p:txBody>
@@ -10389,7 +11189,7 @@
                 </a:solidFill>
                 <a:latin typeface="Calibri"/>
               </a:rPr>
-              <a:t>6/13</a:t>
+              <a:t>6/14</a:t>
             </a:r>
           </a:p>
         </p:txBody>
@@ -11053,7 +11853,7 @@
                 </a:solidFill>
                 <a:latin typeface="Calibri"/>
               </a:rPr>
-              <a:t>7/13</a:t>
+              <a:t>7/14</a:t>
             </a:r>
           </a:p>
         </p:txBody>
@@ -12070,7 +12870,7 @@
                 </a:solidFill>
                 <a:latin typeface="Calibri"/>
               </a:rPr>
-              <a:t>8/13</a:t>
+              <a:t>8/14</a:t>
             </a:r>
           </a:p>
         </p:txBody>
@@ -12734,7 +13534,7 @@
                 </a:solidFill>
                 <a:latin typeface="Calibri"/>
               </a:rPr>
-              <a:t>9/13</a:t>
+              <a:t>9/14</a:t>
             </a:r>
           </a:p>
         </p:txBody>

</xml_diff>